<commit_message>
Capstone-Projekt: Benchmark, Co-Schadstoffe und erweiterte Prophet-Analysen.
Neues Notebook 12 (Co-Schadstoffe/Lag), Benchmark-Excel, Ergebnis-CSVs und Updates an Prophet-, TFT- und Präsentationsdateien.

Co-authored-by: Cursor <cursoragent@cursor.com>
</commit_message>
<xml_diff>
--- a/Capstone Projekt/presentation/Luftverschmutzung in Bejing.pptx
+++ b/Capstone Projekt/presentation/Luftverschmutzung in Bejing.pptx
@@ -5,7 +5,7 @@
     <p:sldMasterId id="2147483648" r:id="rId1"/>
   </p:sldMasterIdLst>
   <p:notesMasterIdLst>
-    <p:notesMasterId r:id="rId11"/>
+    <p:notesMasterId r:id="rId14"/>
   </p:notesMasterIdLst>
   <p:sldIdLst>
     <p:sldId id="256" r:id="rId2"/>
@@ -17,6 +17,9 @@
     <p:sldId id="262" r:id="rId8"/>
     <p:sldId id="263" r:id="rId9"/>
     <p:sldId id="264" r:id="rId10"/>
+    <p:sldId id="266" r:id="rId11"/>
+    <p:sldId id="267" r:id="rId12"/>
+    <p:sldId id="265" r:id="rId13"/>
   </p:sldIdLst>
   <p:sldSz cx="12161838" cy="6858000"/>
   <p:notesSz cx="6858000" cy="9144000"/>
@@ -116,6 +119,30 @@
     </a:lvl9pPr>
   </p:defaultTextStyle>
   <p:extLst>
+    <p:ext uri="{521415D9-36F7-43E2-AB2F-B90AF26B5E84}">
+      <p14:sectionLst xmlns:p14="http://schemas.microsoft.com/office/powerpoint/2010/main">
+        <p14:section name="Standardabschnitt" id="{DF516110-05F4-46BB-9165-FB41E1AA018D}">
+          <p14:sldIdLst>
+            <p14:sldId id="256"/>
+            <p14:sldId id="257"/>
+            <p14:sldId id="258"/>
+            <p14:sldId id="259"/>
+            <p14:sldId id="260"/>
+            <p14:sldId id="261"/>
+            <p14:sldId id="262"/>
+            <p14:sldId id="263"/>
+            <p14:sldId id="264"/>
+          </p14:sldIdLst>
+        </p14:section>
+        <p14:section name="Stoffsammlung" id="{72CF4EF2-1A67-4308-ACC7-5AC41801B1A8}">
+          <p14:sldIdLst>
+            <p14:sldId id="266"/>
+            <p14:sldId id="267"/>
+            <p14:sldId id="265"/>
+          </p14:sldIdLst>
+        </p14:section>
+      </p14:sectionLst>
+    </p:ext>
     <p:ext uri="{EFAFB233-063F-42B5-8137-9DF3F51BA10A}">
       <p15:sldGuideLst xmlns:p15="http://schemas.microsoft.com/office/powerpoint/2012/main">
         <p15:guide id="1" orient="horz" pos="2160">
@@ -1097,7 +1124,7 @@
           <a:p>
             <a:fld id="{5BCAD085-E8A6-8845-BD4E-CB4CCA059FC4}" type="datetimeFigureOut">
               <a:rPr lang="en-US" smtClean="0"/>
-              <a:t>7/11/2026</a:t>
+              <a:t>7/12/2026</a:t>
             </a:fld>
             <a:endParaRPr lang="en-US"/>
           </a:p>
@@ -1265,7 +1292,7 @@
           <a:p>
             <a:fld id="{5BCAD085-E8A6-8845-BD4E-CB4CCA059FC4}" type="datetimeFigureOut">
               <a:rPr lang="en-US" smtClean="0"/>
-              <a:t>7/11/2026</a:t>
+              <a:t>7/12/2026</a:t>
             </a:fld>
             <a:endParaRPr lang="en-US"/>
           </a:p>
@@ -1443,7 +1470,7 @@
           <a:p>
             <a:fld id="{5BCAD085-E8A6-8845-BD4E-CB4CCA059FC4}" type="datetimeFigureOut">
               <a:rPr lang="en-US" smtClean="0"/>
-              <a:t>7/11/2026</a:t>
+              <a:t>7/12/2026</a:t>
             </a:fld>
             <a:endParaRPr lang="en-US"/>
           </a:p>
@@ -1611,7 +1638,7 @@
           <a:p>
             <a:fld id="{5BCAD085-E8A6-8845-BD4E-CB4CCA059FC4}" type="datetimeFigureOut">
               <a:rPr lang="en-US" smtClean="0"/>
-              <a:t>7/11/2026</a:t>
+              <a:t>7/12/2026</a:t>
             </a:fld>
             <a:endParaRPr lang="en-US"/>
           </a:p>
@@ -1856,7 +1883,7 @@
           <a:p>
             <a:fld id="{5BCAD085-E8A6-8845-BD4E-CB4CCA059FC4}" type="datetimeFigureOut">
               <a:rPr lang="en-US" smtClean="0"/>
-              <a:t>7/11/2026</a:t>
+              <a:t>7/12/2026</a:t>
             </a:fld>
             <a:endParaRPr lang="en-US"/>
           </a:p>
@@ -2141,7 +2168,7 @@
           <a:p>
             <a:fld id="{5BCAD085-E8A6-8845-BD4E-CB4CCA059FC4}" type="datetimeFigureOut">
               <a:rPr lang="en-US" smtClean="0"/>
-              <a:t>7/11/2026</a:t>
+              <a:t>7/12/2026</a:t>
             </a:fld>
             <a:endParaRPr lang="en-US"/>
           </a:p>
@@ -2560,7 +2587,7 @@
           <a:p>
             <a:fld id="{5BCAD085-E8A6-8845-BD4E-CB4CCA059FC4}" type="datetimeFigureOut">
               <a:rPr lang="en-US" smtClean="0"/>
-              <a:t>7/11/2026</a:t>
+              <a:t>7/12/2026</a:t>
             </a:fld>
             <a:endParaRPr lang="en-US"/>
           </a:p>
@@ -2677,7 +2704,7 @@
           <a:p>
             <a:fld id="{5BCAD085-E8A6-8845-BD4E-CB4CCA059FC4}" type="datetimeFigureOut">
               <a:rPr lang="en-US" smtClean="0"/>
-              <a:t>7/11/2026</a:t>
+              <a:t>7/12/2026</a:t>
             </a:fld>
             <a:endParaRPr lang="en-US"/>
           </a:p>
@@ -2772,7 +2799,7 @@
           <a:p>
             <a:fld id="{5BCAD085-E8A6-8845-BD4E-CB4CCA059FC4}" type="datetimeFigureOut">
               <a:rPr lang="en-US" smtClean="0"/>
-              <a:t>7/11/2026</a:t>
+              <a:t>7/12/2026</a:t>
             </a:fld>
             <a:endParaRPr lang="en-US"/>
           </a:p>
@@ -3047,7 +3074,7 @@
           <a:p>
             <a:fld id="{5BCAD085-E8A6-8845-BD4E-CB4CCA059FC4}" type="datetimeFigureOut">
               <a:rPr lang="en-US" smtClean="0"/>
-              <a:t>7/11/2026</a:t>
+              <a:t>7/12/2026</a:t>
             </a:fld>
             <a:endParaRPr lang="en-US"/>
           </a:p>
@@ -3299,7 +3326,7 @@
           <a:p>
             <a:fld id="{5BCAD085-E8A6-8845-BD4E-CB4CCA059FC4}" type="datetimeFigureOut">
               <a:rPr lang="en-US" smtClean="0"/>
-              <a:t>7/11/2026</a:t>
+              <a:t>7/12/2026</a:t>
             </a:fld>
             <a:endParaRPr lang="en-US"/>
           </a:p>
@@ -3510,7 +3537,7 @@
           <a:p>
             <a:fld id="{5BCAD085-E8A6-8845-BD4E-CB4CCA059FC4}" type="datetimeFigureOut">
               <a:rPr lang="en-US" smtClean="0"/>
-              <a:t>7/11/2026</a:t>
+              <a:t>7/12/2026</a:t>
             </a:fld>
             <a:endParaRPr lang="en-US"/>
           </a:p>
@@ -4256,6 +4283,249 @@
         </p:txBody>
       </p:sp>
     </p:spTree>
+  </p:cSld>
+  <p:clrMapOvr>
+    <a:masterClrMapping/>
+  </p:clrMapOvr>
+</p:sld>
+</file>
+
+<file path=ppt/slides/slide10.xml><?xml version="1.0" encoding="utf-8"?>
+<p:sld xmlns:a="http://schemas.openxmlformats.org/drawingml/2006/main" xmlns:r="http://schemas.openxmlformats.org/officeDocument/2006/relationships" xmlns:p="http://schemas.openxmlformats.org/presentationml/2006/main">
+  <p:cSld>
+    <p:spTree>
+      <p:nvGrpSpPr>
+        <p:cNvPr id="1" name=""/>
+        <p:cNvGrpSpPr/>
+        <p:nvPr/>
+      </p:nvGrpSpPr>
+      <p:grpSpPr>
+        <a:xfrm>
+          <a:off x="0" y="0"/>
+          <a:ext cx="0" cy="0"/>
+          <a:chOff x="0" y="0"/>
+          <a:chExt cx="0" cy="0"/>
+        </a:xfrm>
+      </p:grpSpPr>
+      <p:pic>
+        <p:nvPicPr>
+          <p:cNvPr id="5" name="Grafik 4">
+            <a:extLst>
+              <a:ext uri="{FF2B5EF4-FFF2-40B4-BE49-F238E27FC236}">
+                <a16:creationId xmlns:a16="http://schemas.microsoft.com/office/drawing/2014/main" id="{C5B2A760-C0DA-4A60-8710-2D77BC18515A}"/>
+              </a:ext>
+            </a:extLst>
+          </p:cNvPr>
+          <p:cNvPicPr>
+            <a:picLocks noChangeAspect="1"/>
+          </p:cNvPicPr>
+          <p:nvPr/>
+        </p:nvPicPr>
+        <p:blipFill>
+          <a:blip r:embed="rId2"/>
+          <a:stretch>
+            <a:fillRect/>
+          </a:stretch>
+        </p:blipFill>
+        <p:spPr>
+          <a:xfrm>
+            <a:off x="2294598" y="1449010"/>
+            <a:ext cx="6855286" cy="4721522"/>
+          </a:xfrm>
+          <a:prstGeom prst="rect">
+            <a:avLst/>
+          </a:prstGeom>
+        </p:spPr>
+      </p:pic>
+      <p:sp>
+        <p:nvSpPr>
+          <p:cNvPr id="6" name="Titel 5">
+            <a:extLst>
+              <a:ext uri="{FF2B5EF4-FFF2-40B4-BE49-F238E27FC236}">
+                <a16:creationId xmlns:a16="http://schemas.microsoft.com/office/drawing/2014/main" id="{4B5C7DD0-3546-9DB9-68C1-D03398AAE4D7}"/>
+              </a:ext>
+            </a:extLst>
+          </p:cNvPr>
+          <p:cNvSpPr>
+            <a:spLocks noGrp="1"/>
+          </p:cNvSpPr>
+          <p:nvPr>
+            <p:ph type="title"/>
+          </p:nvPr>
+        </p:nvSpPr>
+        <p:spPr/>
+        <p:txBody>
+          <a:bodyPr>
+            <a:normAutofit fontScale="90000"/>
+          </a:bodyPr>
+          <a:lstStyle/>
+          <a:p>
+            <a:r>
+              <a:rPr lang="de-DE" dirty="0"/>
+              <a:t>Grenzwerte – WHO Air Quality Guidelines</a:t>
+            </a:r>
+          </a:p>
+        </p:txBody>
+      </p:sp>
+    </p:spTree>
+    <p:extLst>
+      <p:ext uri="{BB962C8B-B14F-4D97-AF65-F5344CB8AC3E}">
+        <p14:creationId xmlns:p14="http://schemas.microsoft.com/office/powerpoint/2010/main" val="2389352749"/>
+      </p:ext>
+    </p:extLst>
+  </p:cSld>
+  <p:clrMapOvr>
+    <a:masterClrMapping/>
+  </p:clrMapOvr>
+</p:sld>
+</file>
+
+<file path=ppt/slides/slide11.xml><?xml version="1.0" encoding="utf-8"?>
+<p:sld xmlns:a="http://schemas.openxmlformats.org/drawingml/2006/main" xmlns:r="http://schemas.openxmlformats.org/officeDocument/2006/relationships" xmlns:p="http://schemas.openxmlformats.org/presentationml/2006/main">
+  <p:cSld>
+    <p:spTree>
+      <p:nvGrpSpPr>
+        <p:cNvPr id="1" name=""/>
+        <p:cNvGrpSpPr/>
+        <p:nvPr/>
+      </p:nvGrpSpPr>
+      <p:grpSpPr>
+        <a:xfrm>
+          <a:off x="0" y="0"/>
+          <a:ext cx="0" cy="0"/>
+          <a:chOff x="0" y="0"/>
+          <a:chExt cx="0" cy="0"/>
+        </a:xfrm>
+      </p:grpSpPr>
+      <p:sp>
+        <p:nvSpPr>
+          <p:cNvPr id="2" name="Titel 1">
+            <a:extLst>
+              <a:ext uri="{FF2B5EF4-FFF2-40B4-BE49-F238E27FC236}">
+                <a16:creationId xmlns:a16="http://schemas.microsoft.com/office/drawing/2014/main" id="{7F527E48-6976-9156-C167-9C5DC1F74661}"/>
+              </a:ext>
+            </a:extLst>
+          </p:cNvPr>
+          <p:cNvSpPr>
+            <a:spLocks noGrp="1"/>
+          </p:cNvSpPr>
+          <p:nvPr>
+            <p:ph type="title"/>
+          </p:nvPr>
+        </p:nvSpPr>
+        <p:spPr/>
+        <p:txBody>
+          <a:bodyPr/>
+          <a:lstStyle/>
+          <a:p>
+            <a:r>
+              <a:rPr lang="de-DE" dirty="0"/>
+              <a:t>Dataset </a:t>
+            </a:r>
+            <a:r>
+              <a:rPr lang="de-DE" dirty="0" err="1"/>
+              <a:t>statistics</a:t>
+            </a:r>
+            <a:endParaRPr lang="de-DE" dirty="0"/>
+          </a:p>
+        </p:txBody>
+      </p:sp>
+      <p:pic>
+        <p:nvPicPr>
+          <p:cNvPr id="5" name="Grafik 4">
+            <a:extLst>
+              <a:ext uri="{FF2B5EF4-FFF2-40B4-BE49-F238E27FC236}">
+                <a16:creationId xmlns:a16="http://schemas.microsoft.com/office/drawing/2014/main" id="{AAFB761B-50B3-0A45-B631-34E024BF1E51}"/>
+              </a:ext>
+            </a:extLst>
+          </p:cNvPr>
+          <p:cNvPicPr>
+            <a:picLocks noChangeAspect="1"/>
+          </p:cNvPicPr>
+          <p:nvPr/>
+        </p:nvPicPr>
+        <p:blipFill>
+          <a:blip r:embed="rId2"/>
+          <a:stretch>
+            <a:fillRect/>
+          </a:stretch>
+        </p:blipFill>
+        <p:spPr>
+          <a:xfrm>
+            <a:off x="3586792" y="1497042"/>
+            <a:ext cx="4988254" cy="4988254"/>
+          </a:xfrm>
+          <a:prstGeom prst="rect">
+            <a:avLst/>
+          </a:prstGeom>
+        </p:spPr>
+      </p:pic>
+    </p:spTree>
+    <p:extLst>
+      <p:ext uri="{BB962C8B-B14F-4D97-AF65-F5344CB8AC3E}">
+        <p14:creationId xmlns:p14="http://schemas.microsoft.com/office/powerpoint/2010/main" val="631192115"/>
+      </p:ext>
+    </p:extLst>
+  </p:cSld>
+  <p:clrMapOvr>
+    <a:masterClrMapping/>
+  </p:clrMapOvr>
+</p:sld>
+</file>
+
+<file path=ppt/slides/slide12.xml><?xml version="1.0" encoding="utf-8"?>
+<p:sld xmlns:a="http://schemas.openxmlformats.org/drawingml/2006/main" xmlns:r="http://schemas.openxmlformats.org/officeDocument/2006/relationships" xmlns:p="http://schemas.openxmlformats.org/presentationml/2006/main">
+  <p:cSld>
+    <p:spTree>
+      <p:nvGrpSpPr>
+        <p:cNvPr id="1" name=""/>
+        <p:cNvGrpSpPr/>
+        <p:nvPr/>
+      </p:nvGrpSpPr>
+      <p:grpSpPr>
+        <a:xfrm>
+          <a:off x="0" y="0"/>
+          <a:ext cx="0" cy="0"/>
+          <a:chOff x="0" y="0"/>
+          <a:chExt cx="0" cy="0"/>
+        </a:xfrm>
+      </p:grpSpPr>
+      <p:pic>
+        <p:nvPicPr>
+          <p:cNvPr id="3" name="Grafik 2">
+            <a:extLst>
+              <a:ext uri="{FF2B5EF4-FFF2-40B4-BE49-F238E27FC236}">
+                <a16:creationId xmlns:a16="http://schemas.microsoft.com/office/drawing/2014/main" id="{00C9980D-1605-A0B9-6A40-B38DD4677ABB}"/>
+              </a:ext>
+            </a:extLst>
+          </p:cNvPr>
+          <p:cNvPicPr>
+            <a:picLocks noChangeAspect="1"/>
+          </p:cNvPicPr>
+          <p:nvPr/>
+        </p:nvPicPr>
+        <p:blipFill>
+          <a:blip r:embed="rId2"/>
+          <a:stretch>
+            <a:fillRect/>
+          </a:stretch>
+        </p:blipFill>
+        <p:spPr>
+          <a:xfrm>
+            <a:off x="3099441" y="1095255"/>
+            <a:ext cx="5962956" cy="4667490"/>
+          </a:xfrm>
+          <a:prstGeom prst="rect">
+            <a:avLst/>
+          </a:prstGeom>
+        </p:spPr>
+      </p:pic>
+    </p:spTree>
+    <p:extLst>
+      <p:ext uri="{BB962C8B-B14F-4D97-AF65-F5344CB8AC3E}">
+        <p14:creationId xmlns:p14="http://schemas.microsoft.com/office/powerpoint/2010/main" val="552023779"/>
+      </p:ext>
+    </p:extLst>
   </p:cSld>
   <p:clrMapOvr>
     <a:masterClrMapping/>

</xml_diff>